<commit_message>
Improve PPTX workflow, validation deck, and README sync
</commit_message>
<xml_diff>
--- a/scripts/example-helpers.pptx
+++ b/scripts/example-helpers.pptx
@@ -5,16 +5,16 @@
     <p:sldMasterId id="2147483648" r:id="rId1"/>
   </p:sldMasterIdLst>
   <p:sldIdLst>
-    <p:sldId id="256" r:id="rId7"/>
-    <p:sldId id="257" r:id="rId8"/>
-    <p:sldId id="258" r:id="rId9"/>
-    <p:sldId id="259" r:id="rId10"/>
-    <p:sldId id="260" r:id="rId11"/>
-    <p:sldId id="261" r:id="rId12"/>
-    <p:sldId id="262" r:id="rId13"/>
-    <p:sldId id="263" r:id="rId14"/>
+    <p:sldId id="256" r:id="rId2"/>
+    <p:sldId id="257" r:id="rId3"/>
+    <p:sldId id="258" r:id="rId4"/>
+    <p:sldId id="259" r:id="rId5"/>
+    <p:sldId id="260" r:id="rId6"/>
+    <p:sldId id="261" r:id="rId7"/>
+    <p:sldId id="262" r:id="rId8"/>
+    <p:sldId id="263" r:id="rId9"/>
   </p:sldIdLst>
-  <p:sldSz cx="12192000" cy="6858000" type="screen4x3"/>
+  <p:sldSz cx="12192000" cy="6858000"/>
   <p:notesSz cx="6858000" cy="9144000"/>
   <p:defaultTextStyle>
     <a:defPPr>
@@ -111,6 +111,22 @@
       </a:defRPr>
     </a:lvl9pPr>
   </p:defaultTextStyle>
+  <p:extLst>
+    <p:ext uri="{EFAFB233-063F-42B5-8137-9DF3F51BA10A}">
+      <p15:sldGuideLst xmlns:p15="http://schemas.microsoft.com/office/powerpoint/2012/main">
+        <p15:guide id="1" orient="horz" pos="2160">
+          <p15:clr>
+            <a:srgbClr val="A4A3A4"/>
+          </p15:clr>
+        </p15:guide>
+        <p15:guide id="2" pos="2880">
+          <p15:clr>
+            <a:srgbClr val="A4A3A4"/>
+          </p15:clr>
+        </p15:guide>
+      </p15:sldGuideLst>
+    </p:ext>
+  </p:extLst>
 </p:presentation>
 </file>
 
@@ -152,10 +168,9 @@
           <a:lstStyle/>
           <a:p>
             <a:r>
-              <a:rPr lang="en-US" smtClean="0"/>
+              <a:rPr lang="en-US"/>
               <a:t>Click to edit Master title style</a:t>
             </a:r>
-            <a:endParaRPr lang="en-US"/>
           </a:p>
         </p:txBody>
       </p:sp>
@@ -271,10 +286,9 @@
           </a:lstStyle>
           <a:p>
             <a:r>
-              <a:rPr lang="en-US" smtClean="0"/>
+              <a:rPr lang="en-US"/>
               <a:t>Click to edit Master subtitle style</a:t>
             </a:r>
-            <a:endParaRPr lang="en-US"/>
           </a:p>
         </p:txBody>
       </p:sp>
@@ -295,7 +309,7 @@
           <a:p>
             <a:fld id="{5BCAD085-E8A6-8845-BD4E-CB4CCA059FC4}" type="datetimeFigureOut">
               <a:rPr lang="en-US" smtClean="0"/>
-              <a:t>1/27/13</a:t>
+              <a:t>3/19/2026</a:t>
             </a:fld>
             <a:endParaRPr lang="en-US"/>
           </a:p>
@@ -389,10 +403,9 @@
           <a:lstStyle/>
           <a:p>
             <a:r>
-              <a:rPr lang="en-US" smtClean="0"/>
+              <a:rPr lang="en-US"/>
               <a:t>Click to edit Master title style</a:t>
             </a:r>
-            <a:endParaRPr lang="en-US"/>
           </a:p>
         </p:txBody>
       </p:sp>
@@ -413,38 +426,37 @@
           <a:p>
             <a:pPr lvl="0"/>
             <a:r>
-              <a:rPr lang="en-US" smtClean="0"/>
+              <a:rPr lang="en-US"/>
               <a:t>Click to edit Master text styles</a:t>
             </a:r>
           </a:p>
           <a:p>
             <a:pPr lvl="1"/>
             <a:r>
-              <a:rPr lang="en-US" smtClean="0"/>
+              <a:rPr lang="en-US"/>
               <a:t>Second level</a:t>
             </a:r>
           </a:p>
           <a:p>
             <a:pPr lvl="2"/>
             <a:r>
-              <a:rPr lang="en-US" smtClean="0"/>
+              <a:rPr lang="en-US"/>
               <a:t>Third level</a:t>
             </a:r>
           </a:p>
           <a:p>
             <a:pPr lvl="3"/>
             <a:r>
-              <a:rPr lang="en-US" smtClean="0"/>
+              <a:rPr lang="en-US"/>
               <a:t>Fourth level</a:t>
             </a:r>
           </a:p>
           <a:p>
             <a:pPr lvl="4"/>
             <a:r>
-              <a:rPr lang="en-US" smtClean="0"/>
+              <a:rPr lang="en-US"/>
               <a:t>Fifth level</a:t>
             </a:r>
-            <a:endParaRPr lang="en-US"/>
           </a:p>
         </p:txBody>
       </p:sp>
@@ -465,7 +477,7 @@
           <a:p>
             <a:fld id="{5BCAD085-E8A6-8845-BD4E-CB4CCA059FC4}" type="datetimeFigureOut">
               <a:rPr lang="en-US" smtClean="0"/>
-              <a:t>1/27/13</a:t>
+              <a:t>3/19/2026</a:t>
             </a:fld>
             <a:endParaRPr lang="en-US"/>
           </a:p>
@@ -564,10 +576,9 @@
           <a:lstStyle/>
           <a:p>
             <a:r>
-              <a:rPr lang="en-US" smtClean="0"/>
+              <a:rPr lang="en-US"/>
               <a:t>Click to edit Master title style</a:t>
             </a:r>
-            <a:endParaRPr lang="en-US"/>
           </a:p>
         </p:txBody>
       </p:sp>
@@ -593,38 +604,37 @@
           <a:p>
             <a:pPr lvl="0"/>
             <a:r>
-              <a:rPr lang="en-US" smtClean="0"/>
+              <a:rPr lang="en-US"/>
               <a:t>Click to edit Master text styles</a:t>
             </a:r>
           </a:p>
           <a:p>
             <a:pPr lvl="1"/>
             <a:r>
-              <a:rPr lang="en-US" smtClean="0"/>
+              <a:rPr lang="en-US"/>
               <a:t>Second level</a:t>
             </a:r>
           </a:p>
           <a:p>
             <a:pPr lvl="2"/>
             <a:r>
-              <a:rPr lang="en-US" smtClean="0"/>
+              <a:rPr lang="en-US"/>
               <a:t>Third level</a:t>
             </a:r>
           </a:p>
           <a:p>
             <a:pPr lvl="3"/>
             <a:r>
-              <a:rPr lang="en-US" smtClean="0"/>
+              <a:rPr lang="en-US"/>
               <a:t>Fourth level</a:t>
             </a:r>
           </a:p>
           <a:p>
             <a:pPr lvl="4"/>
             <a:r>
-              <a:rPr lang="en-US" smtClean="0"/>
+              <a:rPr lang="en-US"/>
               <a:t>Fifth level</a:t>
             </a:r>
-            <a:endParaRPr lang="en-US"/>
           </a:p>
         </p:txBody>
       </p:sp>
@@ -645,7 +655,7 @@
           <a:p>
             <a:fld id="{5BCAD085-E8A6-8845-BD4E-CB4CCA059FC4}" type="datetimeFigureOut">
               <a:rPr lang="en-US" smtClean="0"/>
-              <a:t>1/27/13</a:t>
+              <a:t>3/19/2026</a:t>
             </a:fld>
             <a:endParaRPr lang="en-US"/>
           </a:p>
@@ -739,10 +749,9 @@
           <a:lstStyle/>
           <a:p>
             <a:r>
-              <a:rPr lang="en-US" smtClean="0"/>
+              <a:rPr lang="en-US"/>
               <a:t>Click to edit Master title style</a:t>
             </a:r>
-            <a:endParaRPr lang="en-US"/>
           </a:p>
         </p:txBody>
       </p:sp>
@@ -763,38 +772,37 @@
           <a:p>
             <a:pPr lvl="0"/>
             <a:r>
-              <a:rPr lang="en-US" smtClean="0"/>
+              <a:rPr lang="en-US"/>
               <a:t>Click to edit Master text styles</a:t>
             </a:r>
           </a:p>
           <a:p>
             <a:pPr lvl="1"/>
             <a:r>
-              <a:rPr lang="en-US" smtClean="0"/>
+              <a:rPr lang="en-US"/>
               <a:t>Second level</a:t>
             </a:r>
           </a:p>
           <a:p>
             <a:pPr lvl="2"/>
             <a:r>
-              <a:rPr lang="en-US" smtClean="0"/>
+              <a:rPr lang="en-US"/>
               <a:t>Third level</a:t>
             </a:r>
           </a:p>
           <a:p>
             <a:pPr lvl="3"/>
             <a:r>
-              <a:rPr lang="en-US" smtClean="0"/>
+              <a:rPr lang="en-US"/>
               <a:t>Fourth level</a:t>
             </a:r>
           </a:p>
           <a:p>
             <a:pPr lvl="4"/>
             <a:r>
-              <a:rPr lang="en-US" smtClean="0"/>
+              <a:rPr lang="en-US"/>
               <a:t>Fifth level</a:t>
             </a:r>
-            <a:endParaRPr lang="en-US"/>
           </a:p>
         </p:txBody>
       </p:sp>
@@ -815,7 +823,7 @@
           <a:p>
             <a:fld id="{5BCAD085-E8A6-8845-BD4E-CB4CCA059FC4}" type="datetimeFigureOut">
               <a:rPr lang="en-US" smtClean="0"/>
-              <a:t>1/27/13</a:t>
+              <a:t>3/19/2026</a:t>
             </a:fld>
             <a:endParaRPr lang="en-US"/>
           </a:p>
@@ -918,10 +926,9 @@
           </a:lstStyle>
           <a:p>
             <a:r>
-              <a:rPr lang="en-US" smtClean="0"/>
+              <a:rPr lang="en-US"/>
               <a:t>Click to edit Master title style</a:t>
             </a:r>
-            <a:endParaRPr lang="en-US"/>
           </a:p>
         </p:txBody>
       </p:sp>
@@ -1038,7 +1045,7 @@
           <a:p>
             <a:pPr lvl="0"/>
             <a:r>
-              <a:rPr lang="en-US" smtClean="0"/>
+              <a:rPr lang="en-US"/>
               <a:t>Click to edit Master text styles</a:t>
             </a:r>
           </a:p>
@@ -1061,7 +1068,7 @@
           <a:p>
             <a:fld id="{5BCAD085-E8A6-8845-BD4E-CB4CCA059FC4}" type="datetimeFigureOut">
               <a:rPr lang="en-US" smtClean="0"/>
-              <a:t>1/27/13</a:t>
+              <a:t>3/19/2026</a:t>
             </a:fld>
             <a:endParaRPr lang="en-US"/>
           </a:p>
@@ -1155,10 +1162,9 @@
           <a:lstStyle/>
           <a:p>
             <a:r>
-              <a:rPr lang="en-US" smtClean="0"/>
+              <a:rPr lang="en-US"/>
               <a:t>Click to edit Master title style</a:t>
             </a:r>
-            <a:endParaRPr lang="en-US"/>
           </a:p>
         </p:txBody>
       </p:sp>
@@ -1212,38 +1218,37 @@
           <a:p>
             <a:pPr lvl="0"/>
             <a:r>
-              <a:rPr lang="en-US" smtClean="0"/>
+              <a:rPr lang="en-US"/>
               <a:t>Click to edit Master text styles</a:t>
             </a:r>
           </a:p>
           <a:p>
             <a:pPr lvl="1"/>
             <a:r>
-              <a:rPr lang="en-US" smtClean="0"/>
+              <a:rPr lang="en-US"/>
               <a:t>Second level</a:t>
             </a:r>
           </a:p>
           <a:p>
             <a:pPr lvl="2"/>
             <a:r>
-              <a:rPr lang="en-US" smtClean="0"/>
+              <a:rPr lang="en-US"/>
               <a:t>Third level</a:t>
             </a:r>
           </a:p>
           <a:p>
             <a:pPr lvl="3"/>
             <a:r>
-              <a:rPr lang="en-US" smtClean="0"/>
+              <a:rPr lang="en-US"/>
               <a:t>Fourth level</a:t>
             </a:r>
           </a:p>
           <a:p>
             <a:pPr lvl="4"/>
             <a:r>
-              <a:rPr lang="en-US" smtClean="0"/>
+              <a:rPr lang="en-US"/>
               <a:t>Fifth level</a:t>
             </a:r>
-            <a:endParaRPr lang="en-US"/>
           </a:p>
         </p:txBody>
       </p:sp>
@@ -1297,38 +1302,37 @@
           <a:p>
             <a:pPr lvl="0"/>
             <a:r>
-              <a:rPr lang="en-US" smtClean="0"/>
+              <a:rPr lang="en-US"/>
               <a:t>Click to edit Master text styles</a:t>
             </a:r>
           </a:p>
           <a:p>
             <a:pPr lvl="1"/>
             <a:r>
-              <a:rPr lang="en-US" smtClean="0"/>
+              <a:rPr lang="en-US"/>
               <a:t>Second level</a:t>
             </a:r>
           </a:p>
           <a:p>
             <a:pPr lvl="2"/>
             <a:r>
-              <a:rPr lang="en-US" smtClean="0"/>
+              <a:rPr lang="en-US"/>
               <a:t>Third level</a:t>
             </a:r>
           </a:p>
           <a:p>
             <a:pPr lvl="3"/>
             <a:r>
-              <a:rPr lang="en-US" smtClean="0"/>
+              <a:rPr lang="en-US"/>
               <a:t>Fourth level</a:t>
             </a:r>
           </a:p>
           <a:p>
             <a:pPr lvl="4"/>
             <a:r>
-              <a:rPr lang="en-US" smtClean="0"/>
+              <a:rPr lang="en-US"/>
               <a:t>Fifth level</a:t>
             </a:r>
-            <a:endParaRPr lang="en-US"/>
           </a:p>
         </p:txBody>
       </p:sp>
@@ -1349,7 +1353,7 @@
           <a:p>
             <a:fld id="{5BCAD085-E8A6-8845-BD4E-CB4CCA059FC4}" type="datetimeFigureOut">
               <a:rPr lang="en-US" smtClean="0"/>
-              <a:t>1/27/13</a:t>
+              <a:t>3/19/2026</a:t>
             </a:fld>
             <a:endParaRPr lang="en-US"/>
           </a:p>
@@ -1447,10 +1451,9 @@
           </a:lstStyle>
           <a:p>
             <a:r>
-              <a:rPr lang="en-US" smtClean="0"/>
+              <a:rPr lang="en-US"/>
               <a:t>Click to edit Master title style</a:t>
             </a:r>
-            <a:endParaRPr lang="en-US"/>
           </a:p>
         </p:txBody>
       </p:sp>
@@ -1513,7 +1516,7 @@
           <a:p>
             <a:pPr lvl="0"/>
             <a:r>
-              <a:rPr lang="en-US" smtClean="0"/>
+              <a:rPr lang="en-US"/>
               <a:t>Click to edit Master text styles</a:t>
             </a:r>
           </a:p>
@@ -1569,38 +1572,37 @@
           <a:p>
             <a:pPr lvl="0"/>
             <a:r>
-              <a:rPr lang="en-US" smtClean="0"/>
+              <a:rPr lang="en-US"/>
               <a:t>Click to edit Master text styles</a:t>
             </a:r>
           </a:p>
           <a:p>
             <a:pPr lvl="1"/>
             <a:r>
-              <a:rPr lang="en-US" smtClean="0"/>
+              <a:rPr lang="en-US"/>
               <a:t>Second level</a:t>
             </a:r>
           </a:p>
           <a:p>
             <a:pPr lvl="2"/>
             <a:r>
-              <a:rPr lang="en-US" smtClean="0"/>
+              <a:rPr lang="en-US"/>
               <a:t>Third level</a:t>
             </a:r>
           </a:p>
           <a:p>
             <a:pPr lvl="3"/>
             <a:r>
-              <a:rPr lang="en-US" smtClean="0"/>
+              <a:rPr lang="en-US"/>
               <a:t>Fourth level</a:t>
             </a:r>
           </a:p>
           <a:p>
             <a:pPr lvl="4"/>
             <a:r>
-              <a:rPr lang="en-US" smtClean="0"/>
+              <a:rPr lang="en-US"/>
               <a:t>Fifth level</a:t>
             </a:r>
-            <a:endParaRPr lang="en-US"/>
           </a:p>
         </p:txBody>
       </p:sp>
@@ -1663,7 +1665,7 @@
           <a:p>
             <a:pPr lvl="0"/>
             <a:r>
-              <a:rPr lang="en-US" smtClean="0"/>
+              <a:rPr lang="en-US"/>
               <a:t>Click to edit Master text styles</a:t>
             </a:r>
           </a:p>
@@ -1719,38 +1721,37 @@
           <a:p>
             <a:pPr lvl="0"/>
             <a:r>
-              <a:rPr lang="en-US" smtClean="0"/>
+              <a:rPr lang="en-US"/>
               <a:t>Click to edit Master text styles</a:t>
             </a:r>
           </a:p>
           <a:p>
             <a:pPr lvl="1"/>
             <a:r>
-              <a:rPr lang="en-US" smtClean="0"/>
+              <a:rPr lang="en-US"/>
               <a:t>Second level</a:t>
             </a:r>
           </a:p>
           <a:p>
             <a:pPr lvl="2"/>
             <a:r>
-              <a:rPr lang="en-US" smtClean="0"/>
+              <a:rPr lang="en-US"/>
               <a:t>Third level</a:t>
             </a:r>
           </a:p>
           <a:p>
             <a:pPr lvl="3"/>
             <a:r>
-              <a:rPr lang="en-US" smtClean="0"/>
+              <a:rPr lang="en-US"/>
               <a:t>Fourth level</a:t>
             </a:r>
           </a:p>
           <a:p>
             <a:pPr lvl="4"/>
             <a:r>
-              <a:rPr lang="en-US" smtClean="0"/>
+              <a:rPr lang="en-US"/>
               <a:t>Fifth level</a:t>
             </a:r>
-            <a:endParaRPr lang="en-US"/>
           </a:p>
         </p:txBody>
       </p:sp>
@@ -1771,7 +1772,7 @@
           <a:p>
             <a:fld id="{5BCAD085-E8A6-8845-BD4E-CB4CCA059FC4}" type="datetimeFigureOut">
               <a:rPr lang="en-US" smtClean="0"/>
-              <a:t>1/27/13</a:t>
+              <a:t>3/19/2026</a:t>
             </a:fld>
             <a:endParaRPr lang="en-US"/>
           </a:p>
@@ -1865,10 +1866,9 @@
           <a:lstStyle/>
           <a:p>
             <a:r>
-              <a:rPr lang="en-US" smtClean="0"/>
+              <a:rPr lang="en-US"/>
               <a:t>Click to edit Master title style</a:t>
             </a:r>
-            <a:endParaRPr lang="en-US"/>
           </a:p>
         </p:txBody>
       </p:sp>
@@ -1889,7 +1889,7 @@
           <a:p>
             <a:fld id="{5BCAD085-E8A6-8845-BD4E-CB4CCA059FC4}" type="datetimeFigureOut">
               <a:rPr lang="en-US" smtClean="0"/>
-              <a:t>1/27/13</a:t>
+              <a:t>3/19/2026</a:t>
             </a:fld>
             <a:endParaRPr lang="en-US"/>
           </a:p>
@@ -1984,7 +1984,7 @@
           <a:p>
             <a:fld id="{5BCAD085-E8A6-8845-BD4E-CB4CCA059FC4}" type="datetimeFigureOut">
               <a:rPr lang="en-US" smtClean="0"/>
-              <a:t>1/27/13</a:t>
+              <a:t>3/19/2026</a:t>
             </a:fld>
             <a:endParaRPr lang="en-US"/>
           </a:p>
@@ -2087,10 +2087,9 @@
           </a:lstStyle>
           <a:p>
             <a:r>
-              <a:rPr lang="en-US" smtClean="0"/>
+              <a:rPr lang="en-US"/>
               <a:t>Click to edit Master title style</a:t>
             </a:r>
-            <a:endParaRPr lang="en-US"/>
           </a:p>
         </p:txBody>
       </p:sp>
@@ -2144,38 +2143,37 @@
           <a:p>
             <a:pPr lvl="0"/>
             <a:r>
-              <a:rPr lang="en-US" smtClean="0"/>
+              <a:rPr lang="en-US"/>
               <a:t>Click to edit Master text styles</a:t>
             </a:r>
           </a:p>
           <a:p>
             <a:pPr lvl="1"/>
             <a:r>
-              <a:rPr lang="en-US" smtClean="0"/>
+              <a:rPr lang="en-US"/>
               <a:t>Second level</a:t>
             </a:r>
           </a:p>
           <a:p>
             <a:pPr lvl="2"/>
             <a:r>
-              <a:rPr lang="en-US" smtClean="0"/>
+              <a:rPr lang="en-US"/>
               <a:t>Third level</a:t>
             </a:r>
           </a:p>
           <a:p>
             <a:pPr lvl="3"/>
             <a:r>
-              <a:rPr lang="en-US" smtClean="0"/>
+              <a:rPr lang="en-US"/>
               <a:t>Fourth level</a:t>
             </a:r>
           </a:p>
           <a:p>
             <a:pPr lvl="4"/>
             <a:r>
-              <a:rPr lang="en-US" smtClean="0"/>
+              <a:rPr lang="en-US"/>
               <a:t>Fifth level</a:t>
             </a:r>
-            <a:endParaRPr lang="en-US"/>
           </a:p>
         </p:txBody>
       </p:sp>
@@ -2238,7 +2236,7 @@
           <a:p>
             <a:pPr lvl="0"/>
             <a:r>
-              <a:rPr lang="en-US" smtClean="0"/>
+              <a:rPr lang="en-US"/>
               <a:t>Click to edit Master text styles</a:t>
             </a:r>
           </a:p>
@@ -2261,7 +2259,7 @@
           <a:p>
             <a:fld id="{5BCAD085-E8A6-8845-BD4E-CB4CCA059FC4}" type="datetimeFigureOut">
               <a:rPr lang="en-US" smtClean="0"/>
-              <a:t>1/27/13</a:t>
+              <a:t>3/19/2026</a:t>
             </a:fld>
             <a:endParaRPr lang="en-US"/>
           </a:p>
@@ -2364,10 +2362,9 @@
           </a:lstStyle>
           <a:p>
             <a:r>
-              <a:rPr lang="en-US" smtClean="0"/>
+              <a:rPr lang="en-US"/>
               <a:t>Click to edit Master title style</a:t>
             </a:r>
-            <a:endParaRPr lang="en-US"/>
           </a:p>
         </p:txBody>
       </p:sp>
@@ -2491,7 +2488,7 @@
           <a:p>
             <a:pPr lvl="0"/>
             <a:r>
-              <a:rPr lang="en-US" smtClean="0"/>
+              <a:rPr lang="en-US"/>
               <a:t>Click to edit Master text styles</a:t>
             </a:r>
           </a:p>
@@ -2514,7 +2511,7 @@
           <a:p>
             <a:fld id="{5BCAD085-E8A6-8845-BD4E-CB4CCA059FC4}" type="datetimeFigureOut">
               <a:rPr lang="en-US" smtClean="0"/>
-              <a:t>1/27/13</a:t>
+              <a:t>3/19/2026</a:t>
             </a:fld>
             <a:endParaRPr lang="en-US"/>
           </a:p>
@@ -2623,10 +2620,9 @@
           <a:lstStyle/>
           <a:p>
             <a:r>
-              <a:rPr lang="en-US" smtClean="0"/>
+              <a:rPr lang="en-US"/>
               <a:t>Click to edit Master title style</a:t>
             </a:r>
-            <a:endParaRPr lang="en-US"/>
           </a:p>
         </p:txBody>
       </p:sp>
@@ -2657,38 +2653,37 @@
           <a:p>
             <a:pPr lvl="0"/>
             <a:r>
-              <a:rPr lang="en-US" smtClean="0"/>
+              <a:rPr lang="en-US"/>
               <a:t>Click to edit Master text styles</a:t>
             </a:r>
           </a:p>
           <a:p>
             <a:pPr lvl="1"/>
             <a:r>
-              <a:rPr lang="en-US" smtClean="0"/>
+              <a:rPr lang="en-US"/>
               <a:t>Second level</a:t>
             </a:r>
           </a:p>
           <a:p>
             <a:pPr lvl="2"/>
             <a:r>
-              <a:rPr lang="en-US" smtClean="0"/>
+              <a:rPr lang="en-US"/>
               <a:t>Third level</a:t>
             </a:r>
           </a:p>
           <a:p>
             <a:pPr lvl="3"/>
             <a:r>
-              <a:rPr lang="en-US" smtClean="0"/>
+              <a:rPr lang="en-US"/>
               <a:t>Fourth level</a:t>
             </a:r>
           </a:p>
           <a:p>
             <a:pPr lvl="4"/>
             <a:r>
-              <a:rPr lang="en-US" smtClean="0"/>
+              <a:rPr lang="en-US"/>
               <a:t>Fifth level</a:t>
             </a:r>
-            <a:endParaRPr lang="en-US"/>
           </a:p>
         </p:txBody>
       </p:sp>
@@ -2727,7 +2722,7 @@
           <a:p>
             <a:fld id="{5BCAD085-E8A6-8845-BD4E-CB4CCA059FC4}" type="datetimeFigureOut">
               <a:rPr lang="en-US" smtClean="0"/>
-              <a:t>1/27/13</a:t>
+              <a:t>3/19/2026</a:t>
             </a:fld>
             <a:endParaRPr lang="en-US"/>
           </a:p>
@@ -3086,7 +3081,7 @@
 </file>
 
 <file path=ppt/slides/slide1.xml><?xml version="1.0" encoding="utf-8"?>
-<p:sld xmlns:a="http://schemas.openxmlformats.org/drawingml/2006/main" xmlns:p="http://schemas.openxmlformats.org/presentationml/2006/main" xmlns:r="http://schemas.openxmlformats.org/officeDocument/2006/relationships">
+<p:sld xmlns:a="http://schemas.openxmlformats.org/drawingml/2006/main" xmlns:r="http://schemas.openxmlformats.org/officeDocument/2006/relationships" xmlns:p="http://schemas.openxmlformats.org/presentationml/2006/main">
   <p:cSld>
     <p:spTree>
       <p:nvGrpSpPr>
@@ -3094,7 +3089,14 @@
         <p:cNvGrpSpPr/>
         <p:nvPr/>
       </p:nvGrpSpPr>
-      <p:grpSpPr/>
+      <p:grpSpPr>
+        <a:xfrm>
+          <a:off x="0" y="0"/>
+          <a:ext cx="0" cy="0"/>
+          <a:chOff x="0" y="0"/>
+          <a:chExt cx="0" cy="0"/>
+        </a:xfrm>
+      </p:grpSpPr>
       <p:sp>
         <p:nvSpPr>
           <p:cNvPr id="2" name="Rectangle 1"/>
@@ -3136,6 +3138,7 @@
           <a:lstStyle/>
           <a:p>
             <a:pPr algn="ctr"/>
+            <a:endParaRPr/>
           </a:p>
         </p:txBody>
       </p:sp>
@@ -3180,6 +3183,7 @@
           <a:lstStyle/>
           <a:p>
             <a:pPr algn="ctr"/>
+            <a:endParaRPr/>
           </a:p>
         </p:txBody>
       </p:sp>
@@ -3224,6 +3228,7 @@
           <a:lstStyle/>
           <a:p>
             <a:pPr algn="ctr"/>
+            <a:endParaRPr/>
           </a:p>
         </p:txBody>
       </p:sp>
@@ -3268,6 +3273,7 @@
           <a:lstStyle/>
           <a:p>
             <a:pPr algn="ctr"/>
+            <a:endParaRPr/>
           </a:p>
         </p:txBody>
       </p:sp>
@@ -3436,7 +3442,7 @@
 </file>
 
 <file path=ppt/slides/slide2.xml><?xml version="1.0" encoding="utf-8"?>
-<p:sld xmlns:a="http://schemas.openxmlformats.org/drawingml/2006/main" xmlns:p="http://schemas.openxmlformats.org/presentationml/2006/main" xmlns:r="http://schemas.openxmlformats.org/officeDocument/2006/relationships">
+<p:sld xmlns:a="http://schemas.openxmlformats.org/drawingml/2006/main" xmlns:r="http://schemas.openxmlformats.org/officeDocument/2006/relationships" xmlns:p="http://schemas.openxmlformats.org/presentationml/2006/main">
   <p:cSld>
     <p:spTree>
       <p:nvGrpSpPr>
@@ -3444,7 +3450,14 @@
         <p:cNvGrpSpPr/>
         <p:nvPr/>
       </p:nvGrpSpPr>
-      <p:grpSpPr/>
+      <p:grpSpPr>
+        <a:xfrm>
+          <a:off x="0" y="0"/>
+          <a:ext cx="0" cy="0"/>
+          <a:chOff x="0" y="0"/>
+          <a:chExt cx="0" cy="0"/>
+        </a:xfrm>
+      </p:grpSpPr>
       <p:sp>
         <p:nvSpPr>
           <p:cNvPr id="2" name="Rectangle 1"/>
@@ -3486,6 +3499,7 @@
           <a:lstStyle/>
           <a:p>
             <a:pPr algn="ctr"/>
+            <a:endParaRPr/>
           </a:p>
         </p:txBody>
       </p:sp>
@@ -3530,6 +3544,7 @@
           <a:lstStyle/>
           <a:p>
             <a:pPr algn="ctr"/>
+            <a:endParaRPr/>
           </a:p>
         </p:txBody>
       </p:sp>
@@ -3613,6 +3628,7 @@
           <a:lstStyle/>
           <a:p>
             <a:pPr algn="ctr"/>
+            <a:endParaRPr/>
           </a:p>
         </p:txBody>
       </p:sp>
@@ -3653,7 +3669,7 @@
           </a:fontRef>
         </p:style>
         <p:txBody>
-          <a:bodyPr rtlCol="0" anchor="ctr" wrap="none"/>
+          <a:bodyPr wrap="none" rtlCol="0" anchor="ctr"/>
           <a:lstStyle/>
           <a:p>
             <a:pPr algn="ctr"/>
@@ -3784,7 +3800,7 @@
           </a:fontRef>
         </p:style>
         <p:txBody>
-          <a:bodyPr rtlCol="0" anchor="ctr" wrap="none"/>
+          <a:bodyPr wrap="none" rtlCol="0" anchor="ctr"/>
           <a:lstStyle/>
           <a:p>
             <a:pPr algn="ctr"/>
@@ -3915,7 +3931,7 @@
           </a:fontRef>
         </p:style>
         <p:txBody>
-          <a:bodyPr rtlCol="0" anchor="ctr" wrap="none"/>
+          <a:bodyPr wrap="none" rtlCol="0" anchor="ctr"/>
           <a:lstStyle/>
           <a:p>
             <a:pPr algn="ctr"/>
@@ -4046,7 +4062,7 @@
           </a:fontRef>
         </p:style>
         <p:txBody>
-          <a:bodyPr rtlCol="0" anchor="ctr" wrap="none"/>
+          <a:bodyPr wrap="none" rtlCol="0" anchor="ctr"/>
           <a:lstStyle/>
           <a:p>
             <a:pPr algn="ctr"/>
@@ -4177,7 +4193,7 @@
           </a:fontRef>
         </p:style>
         <p:txBody>
-          <a:bodyPr rtlCol="0" anchor="ctr" wrap="none"/>
+          <a:bodyPr wrap="none" rtlCol="0" anchor="ctr"/>
           <a:lstStyle/>
           <a:p>
             <a:pPr algn="ctr"/>
@@ -4308,7 +4324,7 @@
           </a:fontRef>
         </p:style>
         <p:txBody>
-          <a:bodyPr rtlCol="0" anchor="ctr" wrap="none"/>
+          <a:bodyPr wrap="none" rtlCol="0" anchor="ctr"/>
           <a:lstStyle/>
           <a:p>
             <a:pPr algn="ctr"/>
@@ -4450,7 +4466,7 @@
 </file>
 
 <file path=ppt/slides/slide3.xml><?xml version="1.0" encoding="utf-8"?>
-<p:sld xmlns:a="http://schemas.openxmlformats.org/drawingml/2006/main" xmlns:p="http://schemas.openxmlformats.org/presentationml/2006/main" xmlns:r="http://schemas.openxmlformats.org/officeDocument/2006/relationships">
+<p:sld xmlns:a="http://schemas.openxmlformats.org/drawingml/2006/main" xmlns:r="http://schemas.openxmlformats.org/officeDocument/2006/relationships" xmlns:p="http://schemas.openxmlformats.org/presentationml/2006/main">
   <p:cSld>
     <p:spTree>
       <p:nvGrpSpPr>
@@ -4458,7 +4474,14 @@
         <p:cNvGrpSpPr/>
         <p:nvPr/>
       </p:nvGrpSpPr>
-      <p:grpSpPr/>
+      <p:grpSpPr>
+        <a:xfrm>
+          <a:off x="0" y="0"/>
+          <a:ext cx="0" cy="0"/>
+          <a:chOff x="0" y="0"/>
+          <a:chExt cx="0" cy="0"/>
+        </a:xfrm>
+      </p:grpSpPr>
       <p:sp>
         <p:nvSpPr>
           <p:cNvPr id="2" name="Rectangle 1"/>
@@ -4500,6 +4523,7 @@
           <a:lstStyle/>
           <a:p>
             <a:pPr algn="ctr"/>
+            <a:endParaRPr/>
           </a:p>
         </p:txBody>
       </p:sp>
@@ -4544,6 +4568,7 @@
           <a:lstStyle/>
           <a:p>
             <a:pPr algn="ctr"/>
+            <a:endParaRPr/>
           </a:p>
         </p:txBody>
       </p:sp>
@@ -4666,6 +4691,7 @@
           <a:lstStyle/>
           <a:p>
             <a:pPr algn="ctr"/>
+            <a:endParaRPr/>
           </a:p>
         </p:txBody>
       </p:sp>
@@ -4710,6 +4736,7 @@
           <a:lstStyle/>
           <a:p>
             <a:pPr algn="ctr"/>
+            <a:endParaRPr/>
           </a:p>
         </p:txBody>
       </p:sp>
@@ -4750,7 +4777,7 @@
           </a:fontRef>
         </p:style>
         <p:txBody>
-          <a:bodyPr rtlCol="0" anchor="ctr" wrap="none"/>
+          <a:bodyPr wrap="none" rtlCol="0" anchor="ctr"/>
           <a:lstStyle/>
           <a:p>
             <a:pPr algn="ctr"/>
@@ -4846,6 +4873,7 @@
           <a:lstStyle/>
           <a:p>
             <a:pPr algn="ctr"/>
+            <a:endParaRPr/>
           </a:p>
         </p:txBody>
       </p:sp>
@@ -5044,6 +5072,7 @@
           <a:lstStyle/>
           <a:p>
             <a:pPr algn="ctr"/>
+            <a:endParaRPr/>
           </a:p>
         </p:txBody>
       </p:sp>
@@ -5244,6 +5273,7 @@
           <a:lstStyle/>
           <a:p>
             <a:pPr algn="ctr"/>
+            <a:endParaRPr/>
           </a:p>
         </p:txBody>
       </p:sp>
@@ -5481,6 +5511,7 @@
           <a:lstStyle/>
           <a:p>
             <a:pPr algn="ctr"/>
+            <a:endParaRPr/>
           </a:p>
         </p:txBody>
       </p:sp>
@@ -5539,15 +5570,12 @@
                 <a:spcPts val="100"/>
               </a:spcAft>
             </a:pPr>
-            <a:r>
-              <a:rPr sz="1000">
-                <a:solidFill>
-                  <a:srgbClr val="E0E0E0"/>
-                </a:solidFill>
-                <a:latin typeface="Courier New"/>
-              </a:rPr>
-              <a:t/>
-            </a:r>
+            <a:endParaRPr sz="1000">
+              <a:solidFill>
+                <a:srgbClr val="E0E0E0"/>
+              </a:solidFill>
+              <a:latin typeface="Courier New"/>
+            </a:endParaRPr>
           </a:p>
           <a:p>
             <a:pPr>
@@ -5583,15 +5611,12 @@
                 <a:spcPts val="100"/>
               </a:spcAft>
             </a:pPr>
-            <a:r>
-              <a:rPr sz="1000">
-                <a:solidFill>
-                  <a:srgbClr val="E0E0E0"/>
-                </a:solidFill>
-                <a:latin typeface="Courier New"/>
-              </a:rPr>
-              <a:t/>
-            </a:r>
+            <a:endParaRPr sz="1000">
+              <a:solidFill>
+                <a:srgbClr val="E0E0E0"/>
+              </a:solidFill>
+              <a:latin typeface="Courier New"/>
+            </a:endParaRPr>
           </a:p>
           <a:p>
             <a:pPr>
@@ -5709,7 +5734,7 @@
 </file>
 
 <file path=ppt/slides/slide4.xml><?xml version="1.0" encoding="utf-8"?>
-<p:sld xmlns:a="http://schemas.openxmlformats.org/drawingml/2006/main" xmlns:p="http://schemas.openxmlformats.org/presentationml/2006/main" xmlns:r="http://schemas.openxmlformats.org/officeDocument/2006/relationships">
+<p:sld xmlns:a="http://schemas.openxmlformats.org/drawingml/2006/main" xmlns:r="http://schemas.openxmlformats.org/officeDocument/2006/relationships" xmlns:p="http://schemas.openxmlformats.org/presentationml/2006/main">
   <p:cSld>
     <p:spTree>
       <p:nvGrpSpPr>
@@ -5717,7 +5742,14 @@
         <p:cNvGrpSpPr/>
         <p:nvPr/>
       </p:nvGrpSpPr>
-      <p:grpSpPr/>
+      <p:grpSpPr>
+        <a:xfrm>
+          <a:off x="0" y="0"/>
+          <a:ext cx="0" cy="0"/>
+          <a:chOff x="0" y="0"/>
+          <a:chExt cx="0" cy="0"/>
+        </a:xfrm>
+      </p:grpSpPr>
       <p:sp>
         <p:nvSpPr>
           <p:cNvPr id="2" name="Rectangle 1"/>
@@ -5759,6 +5791,7 @@
           <a:lstStyle/>
           <a:p>
             <a:pPr algn="ctr"/>
+            <a:endParaRPr/>
           </a:p>
         </p:txBody>
       </p:sp>
@@ -5803,6 +5836,7 @@
           <a:lstStyle/>
           <a:p>
             <a:pPr algn="ctr"/>
+            <a:endParaRPr/>
           </a:p>
         </p:txBody>
       </p:sp>
@@ -5925,6 +5959,7 @@
           <a:lstStyle/>
           <a:p>
             <a:pPr algn="ctr"/>
+            <a:endParaRPr/>
           </a:p>
         </p:txBody>
       </p:sp>
@@ -5969,6 +6004,7 @@
           <a:lstStyle/>
           <a:p>
             <a:pPr algn="ctr"/>
+            <a:endParaRPr/>
           </a:p>
         </p:txBody>
       </p:sp>
@@ -6009,7 +6045,7 @@
           </a:fontRef>
         </p:style>
         <p:txBody>
-          <a:bodyPr rtlCol="0" anchor="ctr" wrap="none"/>
+          <a:bodyPr wrap="none" rtlCol="0" anchor="ctr"/>
           <a:lstStyle/>
           <a:p>
             <a:pPr algn="ctr"/>
@@ -6083,15 +6119,39 @@
                 <a:tableStyleId>{5C22544A-7EE6-4342-B048-85BDC9FD1C3A}</a:tableStyleId>
               </a:tblPr>
               <a:tblGrid>
-                <a:gridCol w="2000000"/>
-                <a:gridCol w="3200000"/>
-                <a:gridCol w="1500000"/>
-                <a:gridCol w="1500000"/>
+                <a:gridCol w="2000000">
+                  <a:extLst>
+                    <a:ext uri="{9D8B030D-6E8A-4147-A177-3AD203B41FA5}">
+                      <a16:colId xmlns:a16="http://schemas.microsoft.com/office/drawing/2014/main" val="20000"/>
+                    </a:ext>
+                  </a:extLst>
+                </a:gridCol>
+                <a:gridCol w="3200000">
+                  <a:extLst>
+                    <a:ext uri="{9D8B030D-6E8A-4147-A177-3AD203B41FA5}">
+                      <a16:colId xmlns:a16="http://schemas.microsoft.com/office/drawing/2014/main" val="20001"/>
+                    </a:ext>
+                  </a:extLst>
+                </a:gridCol>
+                <a:gridCol w="1500000">
+                  <a:extLst>
+                    <a:ext uri="{9D8B030D-6E8A-4147-A177-3AD203B41FA5}">
+                      <a16:colId xmlns:a16="http://schemas.microsoft.com/office/drawing/2014/main" val="20002"/>
+                    </a:ext>
+                  </a:extLst>
+                </a:gridCol>
+                <a:gridCol w="1500000">
+                  <a:extLst>
+                    <a:ext uri="{9D8B030D-6E8A-4147-A177-3AD203B41FA5}">
+                      <a16:colId xmlns:a16="http://schemas.microsoft.com/office/drawing/2014/main" val="20003"/>
+                    </a:ext>
+                  </a:extLst>
+                </a:gridCol>
               </a:tblGrid>
               <a:tr h="500000">
                 <a:tc>
                   <a:txBody>
-                    <a:bodyPr wrap="square" lIns="72000" rIns="72000" tIns="36000" bIns="36000"/>
+                    <a:bodyPr/>
                     <a:lstStyle/>
                     <a:p>
                       <a:pPr algn="ctr">
@@ -6121,7 +6181,7 @@
                 </a:tc>
                 <a:tc>
                   <a:txBody>
-                    <a:bodyPr wrap="square" lIns="72000" rIns="72000" tIns="36000" bIns="36000"/>
+                    <a:bodyPr/>
                     <a:lstStyle/>
                     <a:p>
                       <a:pPr algn="ctr">
@@ -6151,7 +6211,7 @@
                 </a:tc>
                 <a:tc>
                   <a:txBody>
-                    <a:bodyPr wrap="square" lIns="72000" rIns="72000" tIns="36000" bIns="36000"/>
+                    <a:bodyPr/>
                     <a:lstStyle/>
                     <a:p>
                       <a:pPr algn="ctr">
@@ -6181,7 +6241,7 @@
                 </a:tc>
                 <a:tc>
                   <a:txBody>
-                    <a:bodyPr wrap="square" lIns="72000" rIns="72000" tIns="36000" bIns="36000"/>
+                    <a:bodyPr/>
                     <a:lstStyle/>
                     <a:p>
                       <a:pPr algn="ctr">
@@ -6209,11 +6269,16 @@
                     </a:solidFill>
                   </a:tcPr>
                 </a:tc>
+                <a:extLst>
+                  <a:ext uri="{0D108BD9-81ED-4DB2-BD59-A6C34878D82A}">
+                    <a16:rowId xmlns:a16="http://schemas.microsoft.com/office/drawing/2014/main" val="10000"/>
+                  </a:ext>
+                </a:extLst>
               </a:tr>
               <a:tr h="500000">
                 <a:tc>
                   <a:txBody>
-                    <a:bodyPr wrap="square" lIns="72000" rIns="72000" tIns="36000" bIns="36000"/>
+                    <a:bodyPr/>
                     <a:lstStyle/>
                     <a:p>
                       <a:pPr algn="l">
@@ -6243,7 +6308,7 @@
                 </a:tc>
                 <a:tc>
                   <a:txBody>
-                    <a:bodyPr wrap="square" lIns="72000" rIns="72000" tIns="36000" bIns="36000"/>
+                    <a:bodyPr/>
                     <a:lstStyle/>
                     <a:p>
                       <a:pPr algn="l">
@@ -6273,7 +6338,7 @@
                 </a:tc>
                 <a:tc>
                   <a:txBody>
-                    <a:bodyPr wrap="square" lIns="72000" rIns="72000" tIns="36000" bIns="36000"/>
+                    <a:bodyPr/>
                     <a:lstStyle/>
                     <a:p>
                       <a:pPr algn="l">
@@ -6303,7 +6368,7 @@
                 </a:tc>
                 <a:tc>
                   <a:txBody>
-                    <a:bodyPr wrap="square" lIns="72000" rIns="72000" tIns="36000" bIns="36000"/>
+                    <a:bodyPr/>
                     <a:lstStyle/>
                     <a:p>
                       <a:pPr algn="l">
@@ -6331,11 +6396,16 @@
                     </a:solidFill>
                   </a:tcPr>
                 </a:tc>
+                <a:extLst>
+                  <a:ext uri="{0D108BD9-81ED-4DB2-BD59-A6C34878D82A}">
+                    <a16:rowId xmlns:a16="http://schemas.microsoft.com/office/drawing/2014/main" val="10001"/>
+                  </a:ext>
+                </a:extLst>
               </a:tr>
               <a:tr h="500000">
                 <a:tc>
                   <a:txBody>
-                    <a:bodyPr wrap="square" lIns="72000" rIns="72000" tIns="36000" bIns="36000"/>
+                    <a:bodyPr/>
                     <a:lstStyle/>
                     <a:p>
                       <a:pPr algn="l">
@@ -6361,7 +6431,7 @@
                 </a:tc>
                 <a:tc>
                   <a:txBody>
-                    <a:bodyPr wrap="square" lIns="72000" rIns="72000" tIns="36000" bIns="36000"/>
+                    <a:bodyPr/>
                     <a:lstStyle/>
                     <a:p>
                       <a:pPr algn="l">
@@ -6387,7 +6457,7 @@
                 </a:tc>
                 <a:tc>
                   <a:txBody>
-                    <a:bodyPr wrap="square" lIns="72000" rIns="72000" tIns="36000" bIns="36000"/>
+                    <a:bodyPr/>
                     <a:lstStyle/>
                     <a:p>
                       <a:pPr algn="l">
@@ -6413,7 +6483,7 @@
                 </a:tc>
                 <a:tc>
                   <a:txBody>
-                    <a:bodyPr wrap="square" lIns="72000" rIns="72000" tIns="36000" bIns="36000"/>
+                    <a:bodyPr/>
                     <a:lstStyle/>
                     <a:p>
                       <a:pPr algn="l">
@@ -6437,11 +6507,16 @@
                   </a:txBody>
                   <a:tcPr anchor="ctr"/>
                 </a:tc>
+                <a:extLst>
+                  <a:ext uri="{0D108BD9-81ED-4DB2-BD59-A6C34878D82A}">
+                    <a16:rowId xmlns:a16="http://schemas.microsoft.com/office/drawing/2014/main" val="10002"/>
+                  </a:ext>
+                </a:extLst>
               </a:tr>
               <a:tr h="500000">
                 <a:tc>
                   <a:txBody>
-                    <a:bodyPr wrap="square" lIns="72000" rIns="72000" tIns="36000" bIns="36000"/>
+                    <a:bodyPr/>
                     <a:lstStyle/>
                     <a:p>
                       <a:pPr algn="l">
@@ -6471,7 +6546,7 @@
                 </a:tc>
                 <a:tc>
                   <a:txBody>
-                    <a:bodyPr wrap="square" lIns="72000" rIns="72000" tIns="36000" bIns="36000"/>
+                    <a:bodyPr/>
                     <a:lstStyle/>
                     <a:p>
                       <a:pPr algn="l">
@@ -6501,7 +6576,7 @@
                 </a:tc>
                 <a:tc>
                   <a:txBody>
-                    <a:bodyPr wrap="square" lIns="72000" rIns="72000" tIns="36000" bIns="36000"/>
+                    <a:bodyPr/>
                     <a:lstStyle/>
                     <a:p>
                       <a:pPr algn="l">
@@ -6531,7 +6606,7 @@
                 </a:tc>
                 <a:tc>
                   <a:txBody>
-                    <a:bodyPr wrap="square" lIns="72000" rIns="72000" tIns="36000" bIns="36000"/>
+                    <a:bodyPr/>
                     <a:lstStyle/>
                     <a:p>
                       <a:pPr algn="l">
@@ -6559,11 +6634,16 @@
                     </a:solidFill>
                   </a:tcPr>
                 </a:tc>
+                <a:extLst>
+                  <a:ext uri="{0D108BD9-81ED-4DB2-BD59-A6C34878D82A}">
+                    <a16:rowId xmlns:a16="http://schemas.microsoft.com/office/drawing/2014/main" val="10003"/>
+                  </a:ext>
+                </a:extLst>
               </a:tr>
               <a:tr h="500000">
                 <a:tc>
                   <a:txBody>
-                    <a:bodyPr wrap="square" lIns="72000" rIns="72000" tIns="36000" bIns="36000"/>
+                    <a:bodyPr/>
                     <a:lstStyle/>
                     <a:p>
                       <a:pPr algn="l">
@@ -6589,7 +6669,7 @@
                 </a:tc>
                 <a:tc>
                   <a:txBody>
-                    <a:bodyPr wrap="square" lIns="72000" rIns="72000" tIns="36000" bIns="36000"/>
+                    <a:bodyPr/>
                     <a:lstStyle/>
                     <a:p>
                       <a:pPr algn="l">
@@ -6615,7 +6695,7 @@
                 </a:tc>
                 <a:tc>
                   <a:txBody>
-                    <a:bodyPr wrap="square" lIns="72000" rIns="72000" tIns="36000" bIns="36000"/>
+                    <a:bodyPr/>
                     <a:lstStyle/>
                     <a:p>
                       <a:pPr algn="l">
@@ -6641,7 +6721,7 @@
                 </a:tc>
                 <a:tc>
                   <a:txBody>
-                    <a:bodyPr wrap="square" lIns="72000" rIns="72000" tIns="36000" bIns="36000"/>
+                    <a:bodyPr/>
                     <a:lstStyle/>
                     <a:p>
                       <a:pPr algn="l">
@@ -6665,11 +6745,16 @@
                   </a:txBody>
                   <a:tcPr anchor="ctr"/>
                 </a:tc>
+                <a:extLst>
+                  <a:ext uri="{0D108BD9-81ED-4DB2-BD59-A6C34878D82A}">
+                    <a16:rowId xmlns:a16="http://schemas.microsoft.com/office/drawing/2014/main" val="10004"/>
+                  </a:ext>
+                </a:extLst>
               </a:tr>
               <a:tr h="500000">
                 <a:tc>
                   <a:txBody>
-                    <a:bodyPr wrap="square" lIns="72000" rIns="72000" tIns="36000" bIns="36000"/>
+                    <a:bodyPr/>
                     <a:lstStyle/>
                     <a:p>
                       <a:pPr algn="l">
@@ -6699,7 +6784,7 @@
                 </a:tc>
                 <a:tc>
                   <a:txBody>
-                    <a:bodyPr wrap="square" lIns="72000" rIns="72000" tIns="36000" bIns="36000"/>
+                    <a:bodyPr/>
                     <a:lstStyle/>
                     <a:p>
                       <a:pPr algn="l">
@@ -6729,7 +6814,7 @@
                 </a:tc>
                 <a:tc>
                   <a:txBody>
-                    <a:bodyPr wrap="square" lIns="72000" rIns="72000" tIns="36000" bIns="36000"/>
+                    <a:bodyPr/>
                     <a:lstStyle/>
                     <a:p>
                       <a:pPr algn="l">
@@ -6759,7 +6844,7 @@
                 </a:tc>
                 <a:tc>
                   <a:txBody>
-                    <a:bodyPr wrap="square" lIns="72000" rIns="72000" tIns="36000" bIns="36000"/>
+                    <a:bodyPr/>
                     <a:lstStyle/>
                     <a:p>
                       <a:pPr algn="l">
@@ -6787,11 +6872,16 @@
                     </a:solidFill>
                   </a:tcPr>
                 </a:tc>
+                <a:extLst>
+                  <a:ext uri="{0D108BD9-81ED-4DB2-BD59-A6C34878D82A}">
+                    <a16:rowId xmlns:a16="http://schemas.microsoft.com/office/drawing/2014/main" val="10005"/>
+                  </a:ext>
+                </a:extLst>
               </a:tr>
               <a:tr h="500000">
                 <a:tc>
                   <a:txBody>
-                    <a:bodyPr wrap="square" lIns="72000" rIns="72000" tIns="36000" bIns="36000"/>
+                    <a:bodyPr/>
                     <a:lstStyle/>
                     <a:p>
                       <a:pPr algn="l">
@@ -6817,7 +6907,7 @@
                 </a:tc>
                 <a:tc>
                   <a:txBody>
-                    <a:bodyPr wrap="square" lIns="72000" rIns="72000" tIns="36000" bIns="36000"/>
+                    <a:bodyPr/>
                     <a:lstStyle/>
                     <a:p>
                       <a:pPr algn="l">
@@ -6843,7 +6933,7 @@
                 </a:tc>
                 <a:tc>
                   <a:txBody>
-                    <a:bodyPr wrap="square" lIns="72000" rIns="72000" tIns="36000" bIns="36000"/>
+                    <a:bodyPr/>
                     <a:lstStyle/>
                     <a:p>
                       <a:pPr algn="l">
@@ -6869,7 +6959,7 @@
                 </a:tc>
                 <a:tc>
                   <a:txBody>
-                    <a:bodyPr wrap="square" lIns="72000" rIns="72000" tIns="36000" bIns="36000"/>
+                    <a:bodyPr/>
                     <a:lstStyle/>
                     <a:p>
                       <a:pPr algn="l">
@@ -6893,11 +6983,16 @@
                   </a:txBody>
                   <a:tcPr anchor="ctr"/>
                 </a:tc>
+                <a:extLst>
+                  <a:ext uri="{0D108BD9-81ED-4DB2-BD59-A6C34878D82A}">
+                    <a16:rowId xmlns:a16="http://schemas.microsoft.com/office/drawing/2014/main" val="10006"/>
+                  </a:ext>
+                </a:extLst>
               </a:tr>
               <a:tr h="500000">
                 <a:tc>
                   <a:txBody>
-                    <a:bodyPr wrap="square" lIns="72000" rIns="72000" tIns="36000" bIns="36000"/>
+                    <a:bodyPr/>
                     <a:lstStyle/>
                     <a:p>
                       <a:pPr algn="l">
@@ -6927,7 +7022,7 @@
                 </a:tc>
                 <a:tc>
                   <a:txBody>
-                    <a:bodyPr wrap="square" lIns="72000" rIns="72000" tIns="36000" bIns="36000"/>
+                    <a:bodyPr/>
                     <a:lstStyle/>
                     <a:p>
                       <a:pPr algn="l">
@@ -6957,7 +7052,7 @@
                 </a:tc>
                 <a:tc>
                   <a:txBody>
-                    <a:bodyPr wrap="square" lIns="72000" rIns="72000" tIns="36000" bIns="36000"/>
+                    <a:bodyPr/>
                     <a:lstStyle/>
                     <a:p>
                       <a:pPr algn="l">
@@ -6987,7 +7082,7 @@
                 </a:tc>
                 <a:tc>
                   <a:txBody>
-                    <a:bodyPr wrap="square" lIns="72000" rIns="72000" tIns="36000" bIns="36000"/>
+                    <a:bodyPr/>
                     <a:lstStyle/>
                     <a:p>
                       <a:pPr algn="l">
@@ -7015,11 +7110,16 @@
                     </a:solidFill>
                   </a:tcPr>
                 </a:tc>
+                <a:extLst>
+                  <a:ext uri="{0D108BD9-81ED-4DB2-BD59-A6C34878D82A}">
+                    <a16:rowId xmlns:a16="http://schemas.microsoft.com/office/drawing/2014/main" val="10007"/>
+                  </a:ext>
+                </a:extLst>
               </a:tr>
               <a:tr h="500000">
                 <a:tc>
                   <a:txBody>
-                    <a:bodyPr wrap="square" lIns="72000" rIns="72000" tIns="36000" bIns="36000"/>
+                    <a:bodyPr/>
                     <a:lstStyle/>
                     <a:p>
                       <a:pPr algn="l">
@@ -7045,7 +7145,7 @@
                 </a:tc>
                 <a:tc>
                   <a:txBody>
-                    <a:bodyPr wrap="square" lIns="72000" rIns="72000" tIns="36000" bIns="36000"/>
+                    <a:bodyPr/>
                     <a:lstStyle/>
                     <a:p>
                       <a:pPr algn="l">
@@ -7071,7 +7171,7 @@
                 </a:tc>
                 <a:tc>
                   <a:txBody>
-                    <a:bodyPr wrap="square" lIns="72000" rIns="72000" tIns="36000" bIns="36000"/>
+                    <a:bodyPr/>
                     <a:lstStyle/>
                     <a:p>
                       <a:pPr algn="l">
@@ -7097,7 +7197,7 @@
                 </a:tc>
                 <a:tc>
                   <a:txBody>
-                    <a:bodyPr wrap="square" lIns="72000" rIns="72000" tIns="36000" bIns="36000"/>
+                    <a:bodyPr/>
                     <a:lstStyle/>
                     <a:p>
                       <a:pPr algn="l">
@@ -7121,6 +7221,11 @@
                   </a:txBody>
                   <a:tcPr anchor="ctr"/>
                 </a:tc>
+                <a:extLst>
+                  <a:ext uri="{0D108BD9-81ED-4DB2-BD59-A6C34878D82A}">
+                    <a16:rowId xmlns:a16="http://schemas.microsoft.com/office/drawing/2014/main" val="10008"/>
+                  </a:ext>
+                </a:extLst>
               </a:tr>
             </a:tbl>
           </a:graphicData>
@@ -7167,6 +7272,7 @@
           <a:lstStyle/>
           <a:p>
             <a:pPr algn="ctr"/>
+            <a:endParaRPr/>
           </a:p>
         </p:txBody>
       </p:sp>
@@ -7250,6 +7356,7 @@
           <a:lstStyle/>
           <a:p>
             <a:pPr algn="ctr"/>
+            <a:endParaRPr/>
           </a:p>
         </p:txBody>
       </p:sp>
@@ -7484,15 +7591,12 @@
                 <a:spcPts val="100"/>
               </a:spcAft>
             </a:pPr>
-            <a:r>
-              <a:rPr sz="900">
-                <a:solidFill>
-                  <a:srgbClr val="E0E0E0"/>
-                </a:solidFill>
-                <a:latin typeface="Courier New"/>
-              </a:rPr>
-              <a:t/>
-            </a:r>
+            <a:endParaRPr sz="900">
+              <a:solidFill>
+                <a:srgbClr val="E0E0E0"/>
+              </a:solidFill>
+              <a:latin typeface="Courier New"/>
+            </a:endParaRPr>
           </a:p>
           <a:p>
             <a:pPr>
@@ -7676,7 +7780,7 @@
 </file>
 
 <file path=ppt/slides/slide5.xml><?xml version="1.0" encoding="utf-8"?>
-<p:sld xmlns:a="http://schemas.openxmlformats.org/drawingml/2006/main" xmlns:p="http://schemas.openxmlformats.org/presentationml/2006/main" xmlns:r="http://schemas.openxmlformats.org/officeDocument/2006/relationships">
+<p:sld xmlns:a="http://schemas.openxmlformats.org/drawingml/2006/main" xmlns:r="http://schemas.openxmlformats.org/officeDocument/2006/relationships" xmlns:p="http://schemas.openxmlformats.org/presentationml/2006/main">
   <p:cSld>
     <p:spTree>
       <p:nvGrpSpPr>
@@ -7684,7 +7788,14 @@
         <p:cNvGrpSpPr/>
         <p:nvPr/>
       </p:nvGrpSpPr>
-      <p:grpSpPr/>
+      <p:grpSpPr>
+        <a:xfrm>
+          <a:off x="0" y="0"/>
+          <a:ext cx="0" cy="0"/>
+          <a:chOff x="0" y="0"/>
+          <a:chExt cx="0" cy="0"/>
+        </a:xfrm>
+      </p:grpSpPr>
       <p:sp>
         <p:nvSpPr>
           <p:cNvPr id="2" name="Rectangle 1"/>
@@ -7726,6 +7837,7 @@
           <a:lstStyle/>
           <a:p>
             <a:pPr algn="ctr"/>
+            <a:endParaRPr/>
           </a:p>
         </p:txBody>
       </p:sp>
@@ -7770,6 +7882,7 @@
           <a:lstStyle/>
           <a:p>
             <a:pPr algn="ctr"/>
+            <a:endParaRPr/>
           </a:p>
         </p:txBody>
       </p:sp>
@@ -7892,6 +8005,7 @@
           <a:lstStyle/>
           <a:p>
             <a:pPr algn="ctr"/>
+            <a:endParaRPr/>
           </a:p>
         </p:txBody>
       </p:sp>
@@ -7936,6 +8050,7 @@
           <a:lstStyle/>
           <a:p>
             <a:pPr algn="ctr"/>
+            <a:endParaRPr/>
           </a:p>
         </p:txBody>
       </p:sp>
@@ -7976,7 +8091,7 @@
           </a:fontRef>
         </p:style>
         <p:txBody>
-          <a:bodyPr rtlCol="0" anchor="ctr" wrap="none"/>
+          <a:bodyPr wrap="none" rtlCol="0" anchor="ctr"/>
           <a:lstStyle/>
           <a:p>
             <a:pPr algn="ctr"/>
@@ -8079,7 +8194,7 @@
         <p:spPr>
           <a:xfrm>
             <a:off x="350000" y="1900000"/>
-            <a:ext cx="5500000" cy="1800000"/>
+            <a:ext cx="5500000" cy="1850000"/>
           </a:xfrm>
           <a:prstGeom prst="rect">
             <a:avLst/>
@@ -8111,6 +8226,7 @@
           <a:lstStyle/>
           <a:p>
             <a:pPr algn="ctr"/>
+            <a:endParaRPr/>
           </a:p>
         </p:txBody>
       </p:sp>
@@ -8148,13 +8264,31 @@
               </a:spcAft>
             </a:pPr>
             <a:r>
-              <a:rPr sz="1100">
+              <a:rPr sz="1100" dirty="0">
                 <a:solidFill>
                   <a:srgbClr val="E0E0E0"/>
                 </a:solidFill>
                 <a:latin typeface="Courier New"/>
               </a:rPr>
-              <a:t>from pptx_helpers import *</a:t>
+              <a:t>from </a:t>
+            </a:r>
+            <a:r>
+              <a:rPr sz="1100" dirty="0" err="1">
+                <a:solidFill>
+                  <a:srgbClr val="E0E0E0"/>
+                </a:solidFill>
+                <a:latin typeface="Courier New"/>
+              </a:rPr>
+              <a:t>pptx_helpers</a:t>
+            </a:r>
+            <a:r>
+              <a:rPr sz="1100" dirty="0">
+                <a:solidFill>
+                  <a:srgbClr val="E0E0E0"/>
+                </a:solidFill>
+                <a:latin typeface="Courier New"/>
+              </a:rPr>
+              <a:t> import *</a:t>
             </a:r>
           </a:p>
           <a:p>
@@ -8169,15 +8303,12 @@
                 <a:spcPts val="100"/>
               </a:spcAft>
             </a:pPr>
-            <a:r>
-              <a:rPr sz="1100">
-                <a:solidFill>
-                  <a:srgbClr val="E0E0E0"/>
-                </a:solidFill>
-                <a:latin typeface="Courier New"/>
-              </a:rPr>
-              <a:t/>
-            </a:r>
+            <a:endParaRPr sz="1100" dirty="0">
+              <a:solidFill>
+                <a:srgbClr val="E0E0E0"/>
+              </a:solidFill>
+              <a:latin typeface="Courier New"/>
+            </a:endParaRPr>
           </a:p>
           <a:p>
             <a:pPr>
@@ -8192,13 +8323,49 @@
               </a:spcAft>
             </a:pPr>
             <a:r>
-              <a:rPr sz="1100">
+              <a:rPr sz="1100" dirty="0">
                 <a:solidFill>
                   <a:srgbClr val="E0E0E0"/>
                 </a:solidFill>
                 <a:latin typeface="Courier New"/>
               </a:rPr>
-              <a:t>prs, C = create_prs("navy_teal")</a:t>
+              <a:t>prs, C = </a:t>
+            </a:r>
+            <a:r>
+              <a:rPr sz="1100" dirty="0" err="1">
+                <a:solidFill>
+                  <a:srgbClr val="E0E0E0"/>
+                </a:solidFill>
+                <a:latin typeface="Courier New"/>
+              </a:rPr>
+              <a:t>create_prs</a:t>
+            </a:r>
+            <a:r>
+              <a:rPr sz="1100" dirty="0">
+                <a:solidFill>
+                  <a:srgbClr val="E0E0E0"/>
+                </a:solidFill>
+                <a:latin typeface="Courier New"/>
+              </a:rPr>
+              <a:t>("</a:t>
+            </a:r>
+            <a:r>
+              <a:rPr sz="1100" dirty="0" err="1">
+                <a:solidFill>
+                  <a:srgbClr val="E0E0E0"/>
+                </a:solidFill>
+                <a:latin typeface="Courier New"/>
+              </a:rPr>
+              <a:t>navy_teal</a:t>
+            </a:r>
+            <a:r>
+              <a:rPr sz="1100" dirty="0">
+                <a:solidFill>
+                  <a:srgbClr val="E0E0E0"/>
+                </a:solidFill>
+                <a:latin typeface="Courier New"/>
+              </a:rPr>
+              <a:t>")</a:t>
             </a:r>
           </a:p>
           <a:p>
@@ -8213,15 +8380,12 @@
                 <a:spcPts val="100"/>
               </a:spcAft>
             </a:pPr>
-            <a:r>
-              <a:rPr sz="1100">
-                <a:solidFill>
-                  <a:srgbClr val="E0E0E0"/>
-                </a:solidFill>
-                <a:latin typeface="Courier New"/>
-              </a:rPr>
-              <a:t/>
-            </a:r>
+            <a:endParaRPr sz="1100" dirty="0">
+              <a:solidFill>
+                <a:srgbClr val="E0E0E0"/>
+              </a:solidFill>
+              <a:latin typeface="Courier New"/>
+            </a:endParaRPr>
           </a:p>
           <a:p>
             <a:pPr>
@@ -8236,13 +8400,13 @@
               </a:spcAft>
             </a:pPr>
             <a:r>
-              <a:rPr sz="1100">
+              <a:rPr sz="1100" dirty="0">
                 <a:solidFill>
                   <a:srgbClr val="E0E0E0"/>
                 </a:solidFill>
                 <a:latin typeface="Courier New"/>
               </a:rPr>
-              <a:t># 创建幻灯片</a:t>
+              <a:t>def build_slide_01(prs, C):</a:t>
             </a:r>
           </a:p>
           <a:p>
@@ -8258,13 +8422,49 @@
               </a:spcAft>
             </a:pPr>
             <a:r>
-              <a:rPr sz="1100">
+              <a:rPr sz="1100" dirty="0">
                 <a:solidFill>
                   <a:srgbClr val="E0E0E0"/>
                 </a:solidFill>
                 <a:latin typeface="Courier New"/>
               </a:rPr>
-              <a:t>s = prs.slides.add_slide(prs.slide_layouts[6])</a:t>
+              <a:t>    s = </a:t>
+            </a:r>
+            <a:r>
+              <a:rPr sz="1100" dirty="0" err="1">
+                <a:solidFill>
+                  <a:srgbClr val="E0E0E0"/>
+                </a:solidFill>
+                <a:latin typeface="Courier New"/>
+              </a:rPr>
+              <a:t>prs.slides.add_slide</a:t>
+            </a:r>
+            <a:r>
+              <a:rPr sz="1100" dirty="0">
+                <a:solidFill>
+                  <a:srgbClr val="E0E0E0"/>
+                </a:solidFill>
+                <a:latin typeface="Courier New"/>
+              </a:rPr>
+              <a:t>(</a:t>
+            </a:r>
+            <a:r>
+              <a:rPr sz="1100" dirty="0" err="1">
+                <a:solidFill>
+                  <a:srgbClr val="E0E0E0"/>
+                </a:solidFill>
+                <a:latin typeface="Courier New"/>
+              </a:rPr>
+              <a:t>prs.slide_layouts</a:t>
+            </a:r>
+            <a:r>
+              <a:rPr sz="1100" dirty="0">
+                <a:solidFill>
+                  <a:srgbClr val="E0E0E0"/>
+                </a:solidFill>
+                <a:latin typeface="Courier New"/>
+              </a:rPr>
+              <a:t>[6])</a:t>
             </a:r>
           </a:p>
           <a:p>
@@ -8280,13 +8480,49 @@
               </a:spcAft>
             </a:pPr>
             <a:r>
-              <a:rPr sz="1100">
+              <a:rPr sz="1100" dirty="0">
                 <a:solidFill>
                   <a:srgbClr val="E0E0E0"/>
                 </a:solidFill>
                 <a:latin typeface="Courier New"/>
               </a:rPr>
-              <a:t>bar(s, "标题", "副标题", C=C)</a:t>
+              <a:t>    bar(s, "</a:t>
+            </a:r>
+            <a:r>
+              <a:rPr sz="1100" dirty="0" err="1">
+                <a:solidFill>
+                  <a:srgbClr val="E0E0E0"/>
+                </a:solidFill>
+                <a:latin typeface="Courier New"/>
+              </a:rPr>
+              <a:t>标题</a:t>
+            </a:r>
+            <a:r>
+              <a:rPr sz="1100" dirty="0">
+                <a:solidFill>
+                  <a:srgbClr val="E0E0E0"/>
+                </a:solidFill>
+                <a:latin typeface="Courier New"/>
+              </a:rPr>
+              <a:t>", "</a:t>
+            </a:r>
+            <a:r>
+              <a:rPr sz="1100" dirty="0" err="1">
+                <a:solidFill>
+                  <a:srgbClr val="E0E0E0"/>
+                </a:solidFill>
+                <a:latin typeface="Courier New"/>
+              </a:rPr>
+              <a:t>副标题</a:t>
+            </a:r>
+            <a:r>
+              <a:rPr sz="1100" dirty="0">
+                <a:solidFill>
+                  <a:srgbClr val="E0E0E0"/>
+                </a:solidFill>
+                <a:latin typeface="Courier New"/>
+              </a:rPr>
+              <a:t>", C=C)</a:t>
             </a:r>
           </a:p>
           <a:p>
@@ -8302,13 +8538,31 @@
               </a:spcAft>
             </a:pPr>
             <a:r>
-              <a:rPr sz="1100">
+              <a:rPr sz="1100" dirty="0">
                 <a:solidFill>
                   <a:srgbClr val="E0E0E0"/>
                 </a:solidFill>
                 <a:latin typeface="Courier New"/>
               </a:rPr>
-              <a:t>sn(s, 1, 10, C)</a:t>
+              <a:t>    </a:t>
+            </a:r>
+            <a:r>
+              <a:rPr sz="1100" dirty="0" err="1">
+                <a:solidFill>
+                  <a:srgbClr val="E0E0E0"/>
+                </a:solidFill>
+                <a:latin typeface="Courier New"/>
+              </a:rPr>
+              <a:t>sn</a:t>
+            </a:r>
+            <a:r>
+              <a:rPr sz="1100" dirty="0">
+                <a:solidFill>
+                  <a:srgbClr val="E0E0E0"/>
+                </a:solidFill>
+                <a:latin typeface="Courier New"/>
+              </a:rPr>
+              <a:t>(s, 1, 10, C=C)</a:t>
             </a:r>
           </a:p>
         </p:txBody>
@@ -8393,6 +8647,7 @@
           <a:lstStyle/>
           <a:p>
             <a:pPr algn="ctr"/>
+            <a:endParaRPr/>
           </a:p>
         </p:txBody>
       </p:sp>
@@ -8630,6 +8885,7 @@
           <a:lstStyle/>
           <a:p>
             <a:pPr algn="ctr"/>
+            <a:endParaRPr/>
           </a:p>
         </p:txBody>
       </p:sp>
@@ -8805,6 +9061,7 @@
           <a:lstStyle/>
           <a:p>
             <a:pPr algn="ctr"/>
+            <a:endParaRPr/>
           </a:p>
         </p:txBody>
       </p:sp>
@@ -8987,7 +9244,7 @@
 </file>
 
 <file path=ppt/slides/slide6.xml><?xml version="1.0" encoding="utf-8"?>
-<p:sld xmlns:a="http://schemas.openxmlformats.org/drawingml/2006/main" xmlns:p="http://schemas.openxmlformats.org/presentationml/2006/main" xmlns:r="http://schemas.openxmlformats.org/officeDocument/2006/relationships">
+<p:sld xmlns:a="http://schemas.openxmlformats.org/drawingml/2006/main" xmlns:r="http://schemas.openxmlformats.org/officeDocument/2006/relationships" xmlns:p="http://schemas.openxmlformats.org/presentationml/2006/main">
   <p:cSld>
     <p:spTree>
       <p:nvGrpSpPr>
@@ -8995,7 +9252,14 @@
         <p:cNvGrpSpPr/>
         <p:nvPr/>
       </p:nvGrpSpPr>
-      <p:grpSpPr/>
+      <p:grpSpPr>
+        <a:xfrm>
+          <a:off x="0" y="0"/>
+          <a:ext cx="0" cy="0"/>
+          <a:chOff x="0" y="0"/>
+          <a:chExt cx="0" cy="0"/>
+        </a:xfrm>
+      </p:grpSpPr>
       <p:sp>
         <p:nvSpPr>
           <p:cNvPr id="2" name="Rectangle 1"/>
@@ -9037,6 +9301,7 @@
           <a:lstStyle/>
           <a:p>
             <a:pPr algn="ctr"/>
+            <a:endParaRPr/>
           </a:p>
         </p:txBody>
       </p:sp>
@@ -9081,6 +9346,7 @@
           <a:lstStyle/>
           <a:p>
             <a:pPr algn="ctr"/>
+            <a:endParaRPr/>
           </a:p>
         </p:txBody>
       </p:sp>
@@ -9203,6 +9469,7 @@
           <a:lstStyle/>
           <a:p>
             <a:pPr algn="ctr"/>
+            <a:endParaRPr/>
           </a:p>
         </p:txBody>
       </p:sp>
@@ -9247,6 +9514,7 @@
           <a:lstStyle/>
           <a:p>
             <a:pPr algn="ctr"/>
+            <a:endParaRPr/>
           </a:p>
         </p:txBody>
       </p:sp>
@@ -9287,7 +9555,7 @@
           </a:fontRef>
         </p:style>
         <p:txBody>
-          <a:bodyPr rtlCol="0" anchor="ctr" wrap="none"/>
+          <a:bodyPr wrap="none" rtlCol="0" anchor="ctr"/>
           <a:lstStyle/>
           <a:p>
             <a:pPr algn="ctr"/>
@@ -9418,7 +9686,7 @@
           </a:fontRef>
         </p:style>
         <p:txBody>
-          <a:bodyPr rtlCol="0" anchor="ctr" wrap="none"/>
+          <a:bodyPr wrap="none" rtlCol="0" anchor="ctr"/>
           <a:lstStyle/>
           <a:p>
             <a:pPr algn="ctr"/>
@@ -9471,7 +9739,7 @@
           </a:fontRef>
         </p:style>
         <p:txBody>
-          <a:bodyPr rtlCol="0" anchor="ctr" wrap="none"/>
+          <a:bodyPr wrap="none" rtlCol="0" anchor="ctr"/>
           <a:lstStyle/>
           <a:p>
             <a:pPr algn="ctr"/>
@@ -9524,7 +9792,7 @@
           </a:fontRef>
         </p:style>
         <p:txBody>
-          <a:bodyPr rtlCol="0" anchor="ctr" wrap="none"/>
+          <a:bodyPr wrap="none" rtlCol="0" anchor="ctr"/>
           <a:lstStyle/>
           <a:p>
             <a:pPr algn="ctr"/>
@@ -9577,7 +9845,7 @@
           </a:fontRef>
         </p:style>
         <p:txBody>
-          <a:bodyPr rtlCol="0" anchor="ctr" wrap="none"/>
+          <a:bodyPr wrap="none" rtlCol="0" anchor="ctr"/>
           <a:lstStyle/>
           <a:p>
             <a:pPr algn="ctr"/>
@@ -9630,7 +9898,7 @@
           </a:fontRef>
         </p:style>
         <p:txBody>
-          <a:bodyPr rtlCol="0" anchor="ctr" wrap="none"/>
+          <a:bodyPr wrap="none" rtlCol="0" anchor="ctr"/>
           <a:lstStyle/>
           <a:p>
             <a:pPr algn="ctr"/>
@@ -9683,7 +9951,7 @@
           </a:fontRef>
         </p:style>
         <p:txBody>
-          <a:bodyPr rtlCol="0" anchor="ctr" wrap="none"/>
+          <a:bodyPr wrap="none" rtlCol="0" anchor="ctr"/>
           <a:lstStyle/>
           <a:p>
             <a:pPr algn="ctr"/>
@@ -9779,6 +10047,7 @@
           <a:lstStyle/>
           <a:p>
             <a:pPr algn="ctr"/>
+            <a:endParaRPr/>
           </a:p>
         </p:txBody>
       </p:sp>
@@ -9819,7 +10088,7 @@
           </a:fontRef>
         </p:style>
         <p:txBody>
-          <a:bodyPr rtlCol="0" anchor="ctr" wrap="none"/>
+          <a:bodyPr wrap="none" rtlCol="0" anchor="ctr"/>
           <a:lstStyle/>
           <a:p>
             <a:pPr algn="ctr"/>
@@ -9915,6 +10184,7 @@
           <a:lstStyle/>
           <a:p>
             <a:pPr algn="ctr"/>
+            <a:endParaRPr/>
           </a:p>
         </p:txBody>
       </p:sp>
@@ -9955,7 +10225,7 @@
           </a:fontRef>
         </p:style>
         <p:txBody>
-          <a:bodyPr rtlCol="0" anchor="ctr" wrap="none"/>
+          <a:bodyPr wrap="none" rtlCol="0" anchor="ctr"/>
           <a:lstStyle/>
           <a:p>
             <a:pPr algn="ctr"/>
@@ -10051,6 +10321,7 @@
           <a:lstStyle/>
           <a:p>
             <a:pPr algn="ctr"/>
+            <a:endParaRPr/>
           </a:p>
         </p:txBody>
       </p:sp>
@@ -10091,7 +10362,7 @@
           </a:fontRef>
         </p:style>
         <p:txBody>
-          <a:bodyPr rtlCol="0" anchor="ctr" wrap="none"/>
+          <a:bodyPr wrap="none" rtlCol="0" anchor="ctr"/>
           <a:lstStyle/>
           <a:p>
             <a:pPr algn="ctr"/>
@@ -10187,6 +10458,7 @@
           <a:lstStyle/>
           <a:p>
             <a:pPr algn="ctr"/>
+            <a:endParaRPr/>
           </a:p>
         </p:txBody>
       </p:sp>
@@ -10227,7 +10499,7 @@
           </a:fontRef>
         </p:style>
         <p:txBody>
-          <a:bodyPr rtlCol="0" anchor="ctr" wrap="none"/>
+          <a:bodyPr wrap="none" rtlCol="0" anchor="ctr"/>
           <a:lstStyle/>
           <a:p>
             <a:pPr algn="ctr"/>
@@ -10323,6 +10595,7 @@
           <a:lstStyle/>
           <a:p>
             <a:pPr algn="ctr"/>
+            <a:endParaRPr/>
           </a:p>
         </p:txBody>
       </p:sp>
@@ -10381,15 +10654,12 @@
                 <a:spcPts val="100"/>
               </a:spcAft>
             </a:pPr>
-            <a:r>
-              <a:rPr sz="1100">
-                <a:solidFill>
-                  <a:srgbClr val="E0E0E0"/>
-                </a:solidFill>
-                <a:latin typeface="Courier New"/>
-              </a:rPr>
-              <a:t/>
-            </a:r>
+            <a:endParaRPr sz="1100">
+              <a:solidFill>
+                <a:srgbClr val="E0E0E0"/>
+              </a:solidFill>
+              <a:latin typeface="Courier New"/>
+            </a:endParaRPr>
           </a:p>
           <a:p>
             <a:pPr>
@@ -10463,7 +10733,7 @@
 </file>
 
 <file path=ppt/slides/slide7.xml><?xml version="1.0" encoding="utf-8"?>
-<p:sld xmlns:a="http://schemas.openxmlformats.org/drawingml/2006/main" xmlns:p="http://schemas.openxmlformats.org/presentationml/2006/main" xmlns:r="http://schemas.openxmlformats.org/officeDocument/2006/relationships">
+<p:sld xmlns:a="http://schemas.openxmlformats.org/drawingml/2006/main" xmlns:r="http://schemas.openxmlformats.org/officeDocument/2006/relationships" xmlns:p="http://schemas.openxmlformats.org/presentationml/2006/main">
   <p:cSld>
     <p:spTree>
       <p:nvGrpSpPr>
@@ -10471,7 +10741,14 @@
         <p:cNvGrpSpPr/>
         <p:nvPr/>
       </p:nvGrpSpPr>
-      <p:grpSpPr/>
+      <p:grpSpPr>
+        <a:xfrm>
+          <a:off x="0" y="0"/>
+          <a:ext cx="0" cy="0"/>
+          <a:chOff x="0" y="0"/>
+          <a:chExt cx="0" cy="0"/>
+        </a:xfrm>
+      </p:grpSpPr>
       <p:sp>
         <p:nvSpPr>
           <p:cNvPr id="2" name="Rectangle 1"/>
@@ -10513,6 +10790,7 @@
           <a:lstStyle/>
           <a:p>
             <a:pPr algn="ctr"/>
+            <a:endParaRPr/>
           </a:p>
         </p:txBody>
       </p:sp>
@@ -10557,6 +10835,7 @@
           <a:lstStyle/>
           <a:p>
             <a:pPr algn="ctr"/>
+            <a:endParaRPr/>
           </a:p>
         </p:txBody>
       </p:sp>
@@ -10679,6 +10958,7 @@
           <a:lstStyle/>
           <a:p>
             <a:pPr algn="ctr"/>
+            <a:endParaRPr/>
           </a:p>
         </p:txBody>
       </p:sp>
@@ -10917,15 +11197,39 @@
                 <a:tableStyleId>{5C22544A-7EE6-4342-B048-85BDC9FD1C3A}</a:tableStyleId>
               </a:tblPr>
               <a:tblGrid>
-                <a:gridCol w="1200000"/>
-                <a:gridCol w="1500000"/>
-                <a:gridCol w="1500000"/>
-                <a:gridCol w="1800000"/>
+                <a:gridCol w="1200000">
+                  <a:extLst>
+                    <a:ext uri="{9D8B030D-6E8A-4147-A177-3AD203B41FA5}">
+                      <a16:colId xmlns:a16="http://schemas.microsoft.com/office/drawing/2014/main" val="20000"/>
+                    </a:ext>
+                  </a:extLst>
+                </a:gridCol>
+                <a:gridCol w="1500000">
+                  <a:extLst>
+                    <a:ext uri="{9D8B030D-6E8A-4147-A177-3AD203B41FA5}">
+                      <a16:colId xmlns:a16="http://schemas.microsoft.com/office/drawing/2014/main" val="20001"/>
+                    </a:ext>
+                  </a:extLst>
+                </a:gridCol>
+                <a:gridCol w="1500000">
+                  <a:extLst>
+                    <a:ext uri="{9D8B030D-6E8A-4147-A177-3AD203B41FA5}">
+                      <a16:colId xmlns:a16="http://schemas.microsoft.com/office/drawing/2014/main" val="20002"/>
+                    </a:ext>
+                  </a:extLst>
+                </a:gridCol>
+                <a:gridCol w="1800000">
+                  <a:extLst>
+                    <a:ext uri="{9D8B030D-6E8A-4147-A177-3AD203B41FA5}">
+                      <a16:colId xmlns:a16="http://schemas.microsoft.com/office/drawing/2014/main" val="20003"/>
+                    </a:ext>
+                  </a:extLst>
+                </a:gridCol>
               </a:tblGrid>
               <a:tr h="500000">
                 <a:tc>
                   <a:txBody>
-                    <a:bodyPr wrap="square" lIns="72000" rIns="72000" tIns="36000" bIns="36000"/>
+                    <a:bodyPr/>
                     <a:lstStyle/>
                     <a:p>
                       <a:pPr algn="ctr">
@@ -10955,7 +11259,7 @@
                 </a:tc>
                 <a:tc>
                   <a:txBody>
-                    <a:bodyPr wrap="square" lIns="72000" rIns="72000" tIns="36000" bIns="36000"/>
+                    <a:bodyPr/>
                     <a:lstStyle/>
                     <a:p>
                       <a:pPr algn="ctr">
@@ -10985,7 +11289,7 @@
                 </a:tc>
                 <a:tc>
                   <a:txBody>
-                    <a:bodyPr wrap="square" lIns="72000" rIns="72000" tIns="36000" bIns="36000"/>
+                    <a:bodyPr/>
                     <a:lstStyle/>
                     <a:p>
                       <a:pPr algn="ctr">
@@ -11015,7 +11319,7 @@
                 </a:tc>
                 <a:tc>
                   <a:txBody>
-                    <a:bodyPr wrap="square" lIns="72000" rIns="72000" tIns="36000" bIns="36000"/>
+                    <a:bodyPr/>
                     <a:lstStyle/>
                     <a:p>
                       <a:pPr algn="ctr">
@@ -11043,11 +11347,16 @@
                     </a:solidFill>
                   </a:tcPr>
                 </a:tc>
+                <a:extLst>
+                  <a:ext uri="{0D108BD9-81ED-4DB2-BD59-A6C34878D82A}">
+                    <a16:rowId xmlns:a16="http://schemas.microsoft.com/office/drawing/2014/main" val="10000"/>
+                  </a:ext>
+                </a:extLst>
               </a:tr>
               <a:tr h="500000">
                 <a:tc>
                   <a:txBody>
-                    <a:bodyPr wrap="square" lIns="72000" rIns="72000" tIns="36000" bIns="36000"/>
+                    <a:bodyPr/>
                     <a:lstStyle/>
                     <a:p>
                       <a:pPr algn="l">
@@ -11077,7 +11386,7 @@
                 </a:tc>
                 <a:tc>
                   <a:txBody>
-                    <a:bodyPr wrap="square" lIns="72000" rIns="72000" tIns="36000" bIns="36000"/>
+                    <a:bodyPr/>
                     <a:lstStyle/>
                     <a:p>
                       <a:pPr algn="l">
@@ -11107,7 +11416,7 @@
                 </a:tc>
                 <a:tc>
                   <a:txBody>
-                    <a:bodyPr wrap="square" lIns="72000" rIns="72000" tIns="36000" bIns="36000"/>
+                    <a:bodyPr/>
                     <a:lstStyle/>
                     <a:p>
                       <a:pPr algn="l">
@@ -11137,7 +11446,7 @@
                 </a:tc>
                 <a:tc>
                   <a:txBody>
-                    <a:bodyPr wrap="square" lIns="72000" rIns="72000" tIns="36000" bIns="36000"/>
+                    <a:bodyPr/>
                     <a:lstStyle/>
                     <a:p>
                       <a:pPr algn="l">
@@ -11165,11 +11474,16 @@
                     </a:solidFill>
                   </a:tcPr>
                 </a:tc>
+                <a:extLst>
+                  <a:ext uri="{0D108BD9-81ED-4DB2-BD59-A6C34878D82A}">
+                    <a16:rowId xmlns:a16="http://schemas.microsoft.com/office/drawing/2014/main" val="10001"/>
+                  </a:ext>
+                </a:extLst>
               </a:tr>
               <a:tr h="500000">
                 <a:tc>
                   <a:txBody>
-                    <a:bodyPr wrap="square" lIns="72000" rIns="72000" tIns="36000" bIns="36000"/>
+                    <a:bodyPr/>
                     <a:lstStyle/>
                     <a:p>
                       <a:pPr algn="l">
@@ -11195,7 +11509,7 @@
                 </a:tc>
                 <a:tc>
                   <a:txBody>
-                    <a:bodyPr wrap="square" lIns="72000" rIns="72000" tIns="36000" bIns="36000"/>
+                    <a:bodyPr/>
                     <a:lstStyle/>
                     <a:p>
                       <a:pPr algn="l">
@@ -11221,7 +11535,7 @@
                 </a:tc>
                 <a:tc>
                   <a:txBody>
-                    <a:bodyPr wrap="square" lIns="72000" rIns="72000" tIns="36000" bIns="36000"/>
+                    <a:bodyPr/>
                     <a:lstStyle/>
                     <a:p>
                       <a:pPr algn="l">
@@ -11247,7 +11561,7 @@
                 </a:tc>
                 <a:tc>
                   <a:txBody>
-                    <a:bodyPr wrap="square" lIns="72000" rIns="72000" tIns="36000" bIns="36000"/>
+                    <a:bodyPr/>
                     <a:lstStyle/>
                     <a:p>
                       <a:pPr algn="l">
@@ -11271,11 +11585,16 @@
                   </a:txBody>
                   <a:tcPr anchor="ctr"/>
                 </a:tc>
+                <a:extLst>
+                  <a:ext uri="{0D108BD9-81ED-4DB2-BD59-A6C34878D82A}">
+                    <a16:rowId xmlns:a16="http://schemas.microsoft.com/office/drawing/2014/main" val="10002"/>
+                  </a:ext>
+                </a:extLst>
               </a:tr>
               <a:tr h="500000">
                 <a:tc>
                   <a:txBody>
-                    <a:bodyPr wrap="square" lIns="72000" rIns="72000" tIns="36000" bIns="36000"/>
+                    <a:bodyPr/>
                     <a:lstStyle/>
                     <a:p>
                       <a:pPr algn="l">
@@ -11305,7 +11624,7 @@
                 </a:tc>
                 <a:tc>
                   <a:txBody>
-                    <a:bodyPr wrap="square" lIns="72000" rIns="72000" tIns="36000" bIns="36000"/>
+                    <a:bodyPr/>
                     <a:lstStyle/>
                     <a:p>
                       <a:pPr algn="l">
@@ -11335,7 +11654,7 @@
                 </a:tc>
                 <a:tc>
                   <a:txBody>
-                    <a:bodyPr wrap="square" lIns="72000" rIns="72000" tIns="36000" bIns="36000"/>
+                    <a:bodyPr/>
                     <a:lstStyle/>
                     <a:p>
                       <a:pPr algn="l">
@@ -11365,7 +11684,7 @@
                 </a:tc>
                 <a:tc>
                   <a:txBody>
-                    <a:bodyPr wrap="square" lIns="72000" rIns="72000" tIns="36000" bIns="36000"/>
+                    <a:bodyPr/>
                     <a:lstStyle/>
                     <a:p>
                       <a:pPr algn="l">
@@ -11393,6 +11712,11 @@
                     </a:solidFill>
                   </a:tcPr>
                 </a:tc>
+                <a:extLst>
+                  <a:ext uri="{0D108BD9-81ED-4DB2-BD59-A6C34878D82A}">
+                    <a16:rowId xmlns:a16="http://schemas.microsoft.com/office/drawing/2014/main" val="10003"/>
+                  </a:ext>
+                </a:extLst>
               </a:tr>
             </a:tbl>
           </a:graphicData>
@@ -11439,6 +11763,7 @@
           <a:lstStyle/>
           <a:p>
             <a:pPr algn="ctr"/>
+            <a:endParaRPr/>
           </a:p>
         </p:txBody>
       </p:sp>
@@ -11629,15 +11954,12 @@
                 <a:spcPts val="100"/>
               </a:spcAft>
             </a:pPr>
-            <a:r>
-              <a:rPr sz="1000">
-                <a:solidFill>
-                  <a:srgbClr val="E0E0E0"/>
-                </a:solidFill>
-                <a:latin typeface="Courier New"/>
-              </a:rPr>
-              <a:t/>
-            </a:r>
+            <a:endParaRPr sz="1000">
+              <a:solidFill>
+                <a:srgbClr val="E0E0E0"/>
+              </a:solidFill>
+              <a:latin typeface="Courier New"/>
+            </a:endParaRPr>
           </a:p>
           <a:p>
             <a:pPr>
@@ -11658,7 +11980,7 @@
                 </a:solidFill>
                 <a:latin typeface="Courier New"/>
               </a:rPr>
-              <a:t># 切换配色方案</a:t>
+              <a:t># 批次执行 builders</a:t>
             </a:r>
           </a:p>
           <a:p>
@@ -11680,7 +12002,51 @@
                 </a:solidFill>
                 <a:latin typeface="Courier New"/>
               </a:rPr>
-              <a:t>prs, C = create_prs('tech_dark')   # 深色科技风</a:t>
+              <a:t>builder_batches = [</a:t>
+            </a:r>
+          </a:p>
+          <a:p>
+            <a:pPr>
+              <a:lnSpc>
+                <a:spcPct val="120000"/>
+              </a:lnSpc>
+              <a:spcBef>
+                <a:spcPts val="100"/>
+              </a:spcBef>
+              <a:spcAft>
+                <a:spcPts val="100"/>
+              </a:spcAft>
+            </a:pPr>
+            <a:r>
+              <a:rPr sz="1000">
+                <a:solidFill>
+                  <a:srgbClr val="E0E0E0"/>
+                </a:solidFill>
+                <a:latin typeface="Courier New"/>
+              </a:rPr>
+              <a:t>    [build_slide_01, build_slide_02],</a:t>
+            </a:r>
+          </a:p>
+          <a:p>
+            <a:pPr>
+              <a:lnSpc>
+                <a:spcPct val="120000"/>
+              </a:lnSpc>
+              <a:spcBef>
+                <a:spcPts val="100"/>
+              </a:spcBef>
+              <a:spcAft>
+                <a:spcPts val="100"/>
+              </a:spcAft>
+            </a:pPr>
+            <a:r>
+              <a:rPr sz="1000">
+                <a:solidFill>
+                  <a:srgbClr val="E0E0E0"/>
+                </a:solidFill>
+                <a:latin typeface="Courier New"/>
+              </a:rPr>
+              <a:t>]</a:t>
             </a:r>
           </a:p>
           <a:p>
@@ -11755,7 +12121,7 @@
 </file>
 
 <file path=ppt/slides/slide8.xml><?xml version="1.0" encoding="utf-8"?>
-<p:sld xmlns:a="http://schemas.openxmlformats.org/drawingml/2006/main" xmlns:p="http://schemas.openxmlformats.org/presentationml/2006/main" xmlns:r="http://schemas.openxmlformats.org/officeDocument/2006/relationships">
+<p:sld xmlns:a="http://schemas.openxmlformats.org/drawingml/2006/main" xmlns:r="http://schemas.openxmlformats.org/officeDocument/2006/relationships" xmlns:p="http://schemas.openxmlformats.org/presentationml/2006/main">
   <p:cSld>
     <p:spTree>
       <p:nvGrpSpPr>
@@ -11763,7 +12129,14 @@
         <p:cNvGrpSpPr/>
         <p:nvPr/>
       </p:nvGrpSpPr>
-      <p:grpSpPr/>
+      <p:grpSpPr>
+        <a:xfrm>
+          <a:off x="0" y="0"/>
+          <a:ext cx="0" cy="0"/>
+          <a:chOff x="0" y="0"/>
+          <a:chExt cx="0" cy="0"/>
+        </a:xfrm>
+      </p:grpSpPr>
       <p:sp>
         <p:nvSpPr>
           <p:cNvPr id="2" name="Rectangle 1"/>
@@ -11805,6 +12178,7 @@
           <a:lstStyle/>
           <a:p>
             <a:pPr algn="ctr"/>
+            <a:endParaRPr/>
           </a:p>
         </p:txBody>
       </p:sp>
@@ -11849,6 +12223,7 @@
           <a:lstStyle/>
           <a:p>
             <a:pPr algn="ctr"/>
+            <a:endParaRPr/>
           </a:p>
         </p:txBody>
       </p:sp>
@@ -11893,6 +12268,7 @@
           <a:lstStyle/>
           <a:p>
             <a:pPr algn="ctr"/>
+            <a:endParaRPr/>
           </a:p>
         </p:txBody>
       </p:sp>

</xml_diff>